<commit_message>
Added the table of contents.
</commit_message>
<xml_diff>
--- a/DNP3_PLC_Simulator/doc/img/designDoc.pptx
+++ b/DNP3_PLC_Simulator/doc/img/designDoc.pptx
@@ -5639,8 +5639,8 @@
         </p:nvSpPr>
         <p:spPr>
           <a:xfrm>
-            <a:off x="562555" y="907481"/>
-            <a:ext cx="10759373" cy="461665"/>
+            <a:off x="562555" y="594531"/>
+            <a:ext cx="10759373" cy="830997"/>
           </a:xfrm>
           <a:prstGeom prst="rect">
             <a:avLst/>
@@ -5661,7 +5661,7 @@
           <a:p>
             <a:r>
               <a:rPr lang="en-US" sz="2400" b="1" dirty="0"/>
-              <a:t>Python Virtual RTU Simulator With IEEE 1815-2021 DNP3.0 Comm Protocol</a:t>
+              <a:t>Python Virtual RTU Simulator With IEEE 1815-2021 DNP3.0 Communication  Protocol and Integrate with PowerGrid Generator Cyber Twin System</a:t>
             </a:r>
             <a:endParaRPr lang="en-SG" sz="2400" b="1" dirty="0"/>
           </a:p>

</xml_diff>